<commit_message>
Five 'your creators' boxes; slimmer template deck
Co-Authored-By: Claude Fable 5.1 <noreply@anthropic.com>
</commit_message>
<xml_diff>
--- a/The Audit Masterclass Template.pptx
+++ b/The Audit Masterclass Template.pptx
@@ -137,7 +137,7 @@
   <p:extLst>
     <p:ext uri="{521415D9-36F7-43E2-AB2F-B90AF26B5E84}">
       <p14:sectionLst xmlns:p14="http://schemas.microsoft.com/office/powerpoint/2010/main">
-        <p14:section name="Open" id="{26963946-d69a-ce7f-e7fb-b472dce3d2ee}">
+        <p14:section name="Open" id="{65dae5b8-9003-1cae-79eb-3a1d05f5b8bd}">
           <p14:sldIdLst>
             <p14:sldId id="256"/>
             <p14:sldId id="257"/>
@@ -148,25 +148,25 @@
             <p14:sldId id="262"/>
           </p14:sldIdLst>
         </p14:section>
-        <p14:section name="My story" id="{2bdc36a3-2565-e1ff-0cf5-515cbe31d0cf}">
+        <p14:section name="My story" id="{8f2bfccc-018d-5df6-de6d-38949eeef02e}">
           <p14:sldIdLst>
             <p14:sldId id="263"/>
             <p14:sldId id="264"/>
           </p14:sldIdLst>
         </p14:section>
-        <p14:section name="The real problem" id="{5cac4fd9-5011-3862-8e84-8d9ccddb20b9}">
+        <p14:section name="The real problem" id="{cbfb6fdd-5689-a6a9-0619-979033648d89}">
           <p14:sldIdLst>
             <p14:sldId id="265"/>
             <p14:sldId id="266"/>
             <p14:sldId id="267"/>
           </p14:sldIdLst>
         </p14:section>
-        <p14:section name="Who you become" id="{92ba5db7-6a8f-8a00-242a-58095411980c}">
+        <p14:section name="Who you become" id="{de23fc93-3188-2295-1cec-4e2797aef089}">
           <p14:sldIdLst>
             <p14:sldId id="268"/>
           </p14:sldIdLst>
         </p14:section>
-        <p14:section name="The method" id="{20d3080e-fe81-ecdc-a3bc-93b1be22734e}">
+        <p14:section name="The method" id="{eb55841b-d720-be5d-58bc-d28d00a76285}">
           <p14:sldIdLst>
             <p14:sldId id="269"/>
             <p14:sldId id="270"/>
@@ -182,13 +182,13 @@
             <p14:sldId id="280"/>
           </p14:sldIdLst>
         </p14:section>
-        <p14:section name="Proof" id="{b52c4b56-9b59-19b2-2808-0766ee7e8446}">
+        <p14:section name="Proof" id="{1e68c2cf-2fdb-06d6-79e4-03fd83d38640}">
           <p14:sldIdLst>
             <p14:sldId id="281"/>
             <p14:sldId id="282"/>
           </p14:sldIdLst>
         </p14:section>
-        <p14:section name="Close" id="{eeea9186-5506-1301-9ef6-24063b032c1e}">
+        <p14:section name="Close" id="{d6d14914-848a-af98-d3af-5541fec43475}">
           <p14:sldIdLst>
             <p14:sldId id="283"/>
             <p14:sldId id="284"/>

</xml_diff>